<commit_message>
fix: restore missing function signature in app.js
</commit_message>
<xml_diff>
--- a/notebooks/EWS_ML_Formulation_July3_2026.pptx
+++ b/notebooks/EWS_ML_Formulation_July3_2026.pptx
@@ -5,18 +5,18 @@
     <p:sldMasterId id="2147483648" r:id="rId1"/>
   </p:sldMasterIdLst>
   <p:sldIdLst>
-    <p:sldId id="256" r:id="rId7"/>
-    <p:sldId id="257" r:id="rId8"/>
-    <p:sldId id="258" r:id="rId9"/>
-    <p:sldId id="259" r:id="rId10"/>
-    <p:sldId id="260" r:id="rId11"/>
-    <p:sldId id="261" r:id="rId12"/>
-    <p:sldId id="262" r:id="rId13"/>
-    <p:sldId id="263" r:id="rId14"/>
-    <p:sldId id="264" r:id="rId15"/>
-    <p:sldId id="265" r:id="rId16"/>
+    <p:sldId id="256" r:id="rId2"/>
+    <p:sldId id="257" r:id="rId3"/>
+    <p:sldId id="258" r:id="rId4"/>
+    <p:sldId id="259" r:id="rId5"/>
+    <p:sldId id="260" r:id="rId6"/>
+    <p:sldId id="261" r:id="rId7"/>
+    <p:sldId id="262" r:id="rId8"/>
+    <p:sldId id="263" r:id="rId9"/>
+    <p:sldId id="264" r:id="rId10"/>
+    <p:sldId id="265" r:id="rId11"/>
   </p:sldIdLst>
-  <p:sldSz cx="12188952" cy="6858000" type="screen4x3"/>
+  <p:sldSz cx="12188825" cy="6858000"/>
   <p:notesSz cx="6858000" cy="9144000"/>
   <p:defaultTextStyle>
     <a:defPPr>
@@ -113,6 +113,22 @@
       </a:defRPr>
     </a:lvl9pPr>
   </p:defaultTextStyle>
+  <p:extLst>
+    <p:ext uri="{EFAFB233-063F-42B5-8137-9DF3F51BA10A}">
+      <p15:sldGuideLst xmlns:p15="http://schemas.microsoft.com/office/powerpoint/2012/main">
+        <p15:guide id="1" orient="horz" pos="2160">
+          <p15:clr>
+            <a:srgbClr val="A4A3A4"/>
+          </p15:clr>
+        </p15:guide>
+        <p15:guide id="2" pos="2880">
+          <p15:clr>
+            <a:srgbClr val="A4A3A4"/>
+          </p15:clr>
+        </p15:guide>
+      </p15:sldGuideLst>
+    </p:ext>
+  </p:extLst>
 </p:presentation>
 </file>
 
@@ -154,10 +170,9 @@
           <a:lstStyle/>
           <a:p>
             <a:r>
-              <a:rPr lang="en-US" smtClean="0"/>
+              <a:rPr lang="en-US"/>
               <a:t>Click to edit Master title style</a:t>
             </a:r>
-            <a:endParaRPr lang="en-US"/>
           </a:p>
         </p:txBody>
       </p:sp>
@@ -273,10 +288,9 @@
           </a:lstStyle>
           <a:p>
             <a:r>
-              <a:rPr lang="en-US" smtClean="0"/>
+              <a:rPr lang="en-US"/>
               <a:t>Click to edit Master subtitle style</a:t>
             </a:r>
-            <a:endParaRPr lang="en-US"/>
           </a:p>
         </p:txBody>
       </p:sp>
@@ -297,7 +311,7 @@
           <a:p>
             <a:fld id="{5BCAD085-E8A6-8845-BD4E-CB4CCA059FC4}" type="datetimeFigureOut">
               <a:rPr lang="en-US" smtClean="0"/>
-              <a:t>1/27/13</a:t>
+              <a:t>7/9/2026</a:t>
             </a:fld>
             <a:endParaRPr lang="en-US"/>
           </a:p>
@@ -391,10 +405,9 @@
           <a:lstStyle/>
           <a:p>
             <a:r>
-              <a:rPr lang="en-US" smtClean="0"/>
+              <a:rPr lang="en-US"/>
               <a:t>Click to edit Master title style</a:t>
             </a:r>
-            <a:endParaRPr lang="en-US"/>
           </a:p>
         </p:txBody>
       </p:sp>
@@ -415,38 +428,37 @@
           <a:p>
             <a:pPr lvl="0"/>
             <a:r>
-              <a:rPr lang="en-US" smtClean="0"/>
+              <a:rPr lang="en-US"/>
               <a:t>Click to edit Master text styles</a:t>
             </a:r>
           </a:p>
           <a:p>
             <a:pPr lvl="1"/>
             <a:r>
-              <a:rPr lang="en-US" smtClean="0"/>
+              <a:rPr lang="en-US"/>
               <a:t>Second level</a:t>
             </a:r>
           </a:p>
           <a:p>
             <a:pPr lvl="2"/>
             <a:r>
-              <a:rPr lang="en-US" smtClean="0"/>
+              <a:rPr lang="en-US"/>
               <a:t>Third level</a:t>
             </a:r>
           </a:p>
           <a:p>
             <a:pPr lvl="3"/>
             <a:r>
-              <a:rPr lang="en-US" smtClean="0"/>
+              <a:rPr lang="en-US"/>
               <a:t>Fourth level</a:t>
             </a:r>
           </a:p>
           <a:p>
             <a:pPr lvl="4"/>
             <a:r>
-              <a:rPr lang="en-US" smtClean="0"/>
+              <a:rPr lang="en-US"/>
               <a:t>Fifth level</a:t>
             </a:r>
-            <a:endParaRPr lang="en-US"/>
           </a:p>
         </p:txBody>
       </p:sp>
@@ -467,7 +479,7 @@
           <a:p>
             <a:fld id="{5BCAD085-E8A6-8845-BD4E-CB4CCA059FC4}" type="datetimeFigureOut">
               <a:rPr lang="en-US" smtClean="0"/>
-              <a:t>1/27/13</a:t>
+              <a:t>7/9/2026</a:t>
             </a:fld>
             <a:endParaRPr lang="en-US"/>
           </a:p>
@@ -566,10 +578,9 @@
           <a:lstStyle/>
           <a:p>
             <a:r>
-              <a:rPr lang="en-US" smtClean="0"/>
+              <a:rPr lang="en-US"/>
               <a:t>Click to edit Master title style</a:t>
             </a:r>
-            <a:endParaRPr lang="en-US"/>
           </a:p>
         </p:txBody>
       </p:sp>
@@ -595,38 +606,37 @@
           <a:p>
             <a:pPr lvl="0"/>
             <a:r>
-              <a:rPr lang="en-US" smtClean="0"/>
+              <a:rPr lang="en-US"/>
               <a:t>Click to edit Master text styles</a:t>
             </a:r>
           </a:p>
           <a:p>
             <a:pPr lvl="1"/>
             <a:r>
-              <a:rPr lang="en-US" smtClean="0"/>
+              <a:rPr lang="en-US"/>
               <a:t>Second level</a:t>
             </a:r>
           </a:p>
           <a:p>
             <a:pPr lvl="2"/>
             <a:r>
-              <a:rPr lang="en-US" smtClean="0"/>
+              <a:rPr lang="en-US"/>
               <a:t>Third level</a:t>
             </a:r>
           </a:p>
           <a:p>
             <a:pPr lvl="3"/>
             <a:r>
-              <a:rPr lang="en-US" smtClean="0"/>
+              <a:rPr lang="en-US"/>
               <a:t>Fourth level</a:t>
             </a:r>
           </a:p>
           <a:p>
             <a:pPr lvl="4"/>
             <a:r>
-              <a:rPr lang="en-US" smtClean="0"/>
+              <a:rPr lang="en-US"/>
               <a:t>Fifth level</a:t>
             </a:r>
-            <a:endParaRPr lang="en-US"/>
           </a:p>
         </p:txBody>
       </p:sp>
@@ -647,7 +657,7 @@
           <a:p>
             <a:fld id="{5BCAD085-E8A6-8845-BD4E-CB4CCA059FC4}" type="datetimeFigureOut">
               <a:rPr lang="en-US" smtClean="0"/>
-              <a:t>1/27/13</a:t>
+              <a:t>7/9/2026</a:t>
             </a:fld>
             <a:endParaRPr lang="en-US"/>
           </a:p>
@@ -741,10 +751,9 @@
           <a:lstStyle/>
           <a:p>
             <a:r>
-              <a:rPr lang="en-US" smtClean="0"/>
+              <a:rPr lang="en-US"/>
               <a:t>Click to edit Master title style</a:t>
             </a:r>
-            <a:endParaRPr lang="en-US"/>
           </a:p>
         </p:txBody>
       </p:sp>
@@ -765,38 +774,37 @@
           <a:p>
             <a:pPr lvl="0"/>
             <a:r>
-              <a:rPr lang="en-US" smtClean="0"/>
+              <a:rPr lang="en-US"/>
               <a:t>Click to edit Master text styles</a:t>
             </a:r>
           </a:p>
           <a:p>
             <a:pPr lvl="1"/>
             <a:r>
-              <a:rPr lang="en-US" smtClean="0"/>
+              <a:rPr lang="en-US"/>
               <a:t>Second level</a:t>
             </a:r>
           </a:p>
           <a:p>
             <a:pPr lvl="2"/>
             <a:r>
-              <a:rPr lang="en-US" smtClean="0"/>
+              <a:rPr lang="en-US"/>
               <a:t>Third level</a:t>
             </a:r>
           </a:p>
           <a:p>
             <a:pPr lvl="3"/>
             <a:r>
-              <a:rPr lang="en-US" smtClean="0"/>
+              <a:rPr lang="en-US"/>
               <a:t>Fourth level</a:t>
             </a:r>
           </a:p>
           <a:p>
             <a:pPr lvl="4"/>
             <a:r>
-              <a:rPr lang="en-US" smtClean="0"/>
+              <a:rPr lang="en-US"/>
               <a:t>Fifth level</a:t>
             </a:r>
-            <a:endParaRPr lang="en-US"/>
           </a:p>
         </p:txBody>
       </p:sp>
@@ -817,7 +825,7 @@
           <a:p>
             <a:fld id="{5BCAD085-E8A6-8845-BD4E-CB4CCA059FC4}" type="datetimeFigureOut">
               <a:rPr lang="en-US" smtClean="0"/>
-              <a:t>1/27/13</a:t>
+              <a:t>7/9/2026</a:t>
             </a:fld>
             <a:endParaRPr lang="en-US"/>
           </a:p>
@@ -920,10 +928,9 @@
           </a:lstStyle>
           <a:p>
             <a:r>
-              <a:rPr lang="en-US" smtClean="0"/>
+              <a:rPr lang="en-US"/>
               <a:t>Click to edit Master title style</a:t>
             </a:r>
-            <a:endParaRPr lang="en-US"/>
           </a:p>
         </p:txBody>
       </p:sp>
@@ -1040,7 +1047,7 @@
           <a:p>
             <a:pPr lvl="0"/>
             <a:r>
-              <a:rPr lang="en-US" smtClean="0"/>
+              <a:rPr lang="en-US"/>
               <a:t>Click to edit Master text styles</a:t>
             </a:r>
           </a:p>
@@ -1063,7 +1070,7 @@
           <a:p>
             <a:fld id="{5BCAD085-E8A6-8845-BD4E-CB4CCA059FC4}" type="datetimeFigureOut">
               <a:rPr lang="en-US" smtClean="0"/>
-              <a:t>1/27/13</a:t>
+              <a:t>7/9/2026</a:t>
             </a:fld>
             <a:endParaRPr lang="en-US"/>
           </a:p>
@@ -1157,10 +1164,9 @@
           <a:lstStyle/>
           <a:p>
             <a:r>
-              <a:rPr lang="en-US" smtClean="0"/>
+              <a:rPr lang="en-US"/>
               <a:t>Click to edit Master title style</a:t>
             </a:r>
-            <a:endParaRPr lang="en-US"/>
           </a:p>
         </p:txBody>
       </p:sp>
@@ -1214,38 +1220,37 @@
           <a:p>
             <a:pPr lvl="0"/>
             <a:r>
-              <a:rPr lang="en-US" smtClean="0"/>
+              <a:rPr lang="en-US"/>
               <a:t>Click to edit Master text styles</a:t>
             </a:r>
           </a:p>
           <a:p>
             <a:pPr lvl="1"/>
             <a:r>
-              <a:rPr lang="en-US" smtClean="0"/>
+              <a:rPr lang="en-US"/>
               <a:t>Second level</a:t>
             </a:r>
           </a:p>
           <a:p>
             <a:pPr lvl="2"/>
             <a:r>
-              <a:rPr lang="en-US" smtClean="0"/>
+              <a:rPr lang="en-US"/>
               <a:t>Third level</a:t>
             </a:r>
           </a:p>
           <a:p>
             <a:pPr lvl="3"/>
             <a:r>
-              <a:rPr lang="en-US" smtClean="0"/>
+              <a:rPr lang="en-US"/>
               <a:t>Fourth level</a:t>
             </a:r>
           </a:p>
           <a:p>
             <a:pPr lvl="4"/>
             <a:r>
-              <a:rPr lang="en-US" smtClean="0"/>
+              <a:rPr lang="en-US"/>
               <a:t>Fifth level</a:t>
             </a:r>
-            <a:endParaRPr lang="en-US"/>
           </a:p>
         </p:txBody>
       </p:sp>
@@ -1299,38 +1304,37 @@
           <a:p>
             <a:pPr lvl="0"/>
             <a:r>
-              <a:rPr lang="en-US" smtClean="0"/>
+              <a:rPr lang="en-US"/>
               <a:t>Click to edit Master text styles</a:t>
             </a:r>
           </a:p>
           <a:p>
             <a:pPr lvl="1"/>
             <a:r>
-              <a:rPr lang="en-US" smtClean="0"/>
+              <a:rPr lang="en-US"/>
               <a:t>Second level</a:t>
             </a:r>
           </a:p>
           <a:p>
             <a:pPr lvl="2"/>
             <a:r>
-              <a:rPr lang="en-US" smtClean="0"/>
+              <a:rPr lang="en-US"/>
               <a:t>Third level</a:t>
             </a:r>
           </a:p>
           <a:p>
             <a:pPr lvl="3"/>
             <a:r>
-              <a:rPr lang="en-US" smtClean="0"/>
+              <a:rPr lang="en-US"/>
               <a:t>Fourth level</a:t>
             </a:r>
           </a:p>
           <a:p>
             <a:pPr lvl="4"/>
             <a:r>
-              <a:rPr lang="en-US" smtClean="0"/>
+              <a:rPr lang="en-US"/>
               <a:t>Fifth level</a:t>
             </a:r>
-            <a:endParaRPr lang="en-US"/>
           </a:p>
         </p:txBody>
       </p:sp>
@@ -1351,7 +1355,7 @@
           <a:p>
             <a:fld id="{5BCAD085-E8A6-8845-BD4E-CB4CCA059FC4}" type="datetimeFigureOut">
               <a:rPr lang="en-US" smtClean="0"/>
-              <a:t>1/27/13</a:t>
+              <a:t>7/9/2026</a:t>
             </a:fld>
             <a:endParaRPr lang="en-US"/>
           </a:p>
@@ -1449,10 +1453,9 @@
           </a:lstStyle>
           <a:p>
             <a:r>
-              <a:rPr lang="en-US" smtClean="0"/>
+              <a:rPr lang="en-US"/>
               <a:t>Click to edit Master title style</a:t>
             </a:r>
-            <a:endParaRPr lang="en-US"/>
           </a:p>
         </p:txBody>
       </p:sp>
@@ -1515,7 +1518,7 @@
           <a:p>
             <a:pPr lvl="0"/>
             <a:r>
-              <a:rPr lang="en-US" smtClean="0"/>
+              <a:rPr lang="en-US"/>
               <a:t>Click to edit Master text styles</a:t>
             </a:r>
           </a:p>
@@ -1571,38 +1574,37 @@
           <a:p>
             <a:pPr lvl="0"/>
             <a:r>
-              <a:rPr lang="en-US" smtClean="0"/>
+              <a:rPr lang="en-US"/>
               <a:t>Click to edit Master text styles</a:t>
             </a:r>
           </a:p>
           <a:p>
             <a:pPr lvl="1"/>
             <a:r>
-              <a:rPr lang="en-US" smtClean="0"/>
+              <a:rPr lang="en-US"/>
               <a:t>Second level</a:t>
             </a:r>
           </a:p>
           <a:p>
             <a:pPr lvl="2"/>
             <a:r>
-              <a:rPr lang="en-US" smtClean="0"/>
+              <a:rPr lang="en-US"/>
               <a:t>Third level</a:t>
             </a:r>
           </a:p>
           <a:p>
             <a:pPr lvl="3"/>
             <a:r>
-              <a:rPr lang="en-US" smtClean="0"/>
+              <a:rPr lang="en-US"/>
               <a:t>Fourth level</a:t>
             </a:r>
           </a:p>
           <a:p>
             <a:pPr lvl="4"/>
             <a:r>
-              <a:rPr lang="en-US" smtClean="0"/>
+              <a:rPr lang="en-US"/>
               <a:t>Fifth level</a:t>
             </a:r>
-            <a:endParaRPr lang="en-US"/>
           </a:p>
         </p:txBody>
       </p:sp>
@@ -1665,7 +1667,7 @@
           <a:p>
             <a:pPr lvl="0"/>
             <a:r>
-              <a:rPr lang="en-US" smtClean="0"/>
+              <a:rPr lang="en-US"/>
               <a:t>Click to edit Master text styles</a:t>
             </a:r>
           </a:p>
@@ -1721,38 +1723,37 @@
           <a:p>
             <a:pPr lvl="0"/>
             <a:r>
-              <a:rPr lang="en-US" smtClean="0"/>
+              <a:rPr lang="en-US"/>
               <a:t>Click to edit Master text styles</a:t>
             </a:r>
           </a:p>
           <a:p>
             <a:pPr lvl="1"/>
             <a:r>
-              <a:rPr lang="en-US" smtClean="0"/>
+              <a:rPr lang="en-US"/>
               <a:t>Second level</a:t>
             </a:r>
           </a:p>
           <a:p>
             <a:pPr lvl="2"/>
             <a:r>
-              <a:rPr lang="en-US" smtClean="0"/>
+              <a:rPr lang="en-US"/>
               <a:t>Third level</a:t>
             </a:r>
           </a:p>
           <a:p>
             <a:pPr lvl="3"/>
             <a:r>
-              <a:rPr lang="en-US" smtClean="0"/>
+              <a:rPr lang="en-US"/>
               <a:t>Fourth level</a:t>
             </a:r>
           </a:p>
           <a:p>
             <a:pPr lvl="4"/>
             <a:r>
-              <a:rPr lang="en-US" smtClean="0"/>
+              <a:rPr lang="en-US"/>
               <a:t>Fifth level</a:t>
             </a:r>
-            <a:endParaRPr lang="en-US"/>
           </a:p>
         </p:txBody>
       </p:sp>
@@ -1773,7 +1774,7 @@
           <a:p>
             <a:fld id="{5BCAD085-E8A6-8845-BD4E-CB4CCA059FC4}" type="datetimeFigureOut">
               <a:rPr lang="en-US" smtClean="0"/>
-              <a:t>1/27/13</a:t>
+              <a:t>7/9/2026</a:t>
             </a:fld>
             <a:endParaRPr lang="en-US"/>
           </a:p>
@@ -1867,10 +1868,9 @@
           <a:lstStyle/>
           <a:p>
             <a:r>
-              <a:rPr lang="en-US" smtClean="0"/>
+              <a:rPr lang="en-US"/>
               <a:t>Click to edit Master title style</a:t>
             </a:r>
-            <a:endParaRPr lang="en-US"/>
           </a:p>
         </p:txBody>
       </p:sp>
@@ -1891,7 +1891,7 @@
           <a:p>
             <a:fld id="{5BCAD085-E8A6-8845-BD4E-CB4CCA059FC4}" type="datetimeFigureOut">
               <a:rPr lang="en-US" smtClean="0"/>
-              <a:t>1/27/13</a:t>
+              <a:t>7/9/2026</a:t>
             </a:fld>
             <a:endParaRPr lang="en-US"/>
           </a:p>
@@ -1986,7 +1986,7 @@
           <a:p>
             <a:fld id="{5BCAD085-E8A6-8845-BD4E-CB4CCA059FC4}" type="datetimeFigureOut">
               <a:rPr lang="en-US" smtClean="0"/>
-              <a:t>1/27/13</a:t>
+              <a:t>7/9/2026</a:t>
             </a:fld>
             <a:endParaRPr lang="en-US"/>
           </a:p>
@@ -2089,10 +2089,9 @@
           </a:lstStyle>
           <a:p>
             <a:r>
-              <a:rPr lang="en-US" smtClean="0"/>
+              <a:rPr lang="en-US"/>
               <a:t>Click to edit Master title style</a:t>
             </a:r>
-            <a:endParaRPr lang="en-US"/>
           </a:p>
         </p:txBody>
       </p:sp>
@@ -2146,38 +2145,37 @@
           <a:p>
             <a:pPr lvl="0"/>
             <a:r>
-              <a:rPr lang="en-US" smtClean="0"/>
+              <a:rPr lang="en-US"/>
               <a:t>Click to edit Master text styles</a:t>
             </a:r>
           </a:p>
           <a:p>
             <a:pPr lvl="1"/>
             <a:r>
-              <a:rPr lang="en-US" smtClean="0"/>
+              <a:rPr lang="en-US"/>
               <a:t>Second level</a:t>
             </a:r>
           </a:p>
           <a:p>
             <a:pPr lvl="2"/>
             <a:r>
-              <a:rPr lang="en-US" smtClean="0"/>
+              <a:rPr lang="en-US"/>
               <a:t>Third level</a:t>
             </a:r>
           </a:p>
           <a:p>
             <a:pPr lvl="3"/>
             <a:r>
-              <a:rPr lang="en-US" smtClean="0"/>
+              <a:rPr lang="en-US"/>
               <a:t>Fourth level</a:t>
             </a:r>
           </a:p>
           <a:p>
             <a:pPr lvl="4"/>
             <a:r>
-              <a:rPr lang="en-US" smtClean="0"/>
+              <a:rPr lang="en-US"/>
               <a:t>Fifth level</a:t>
             </a:r>
-            <a:endParaRPr lang="en-US"/>
           </a:p>
         </p:txBody>
       </p:sp>
@@ -2240,7 +2238,7 @@
           <a:p>
             <a:pPr lvl="0"/>
             <a:r>
-              <a:rPr lang="en-US" smtClean="0"/>
+              <a:rPr lang="en-US"/>
               <a:t>Click to edit Master text styles</a:t>
             </a:r>
           </a:p>
@@ -2263,7 +2261,7 @@
           <a:p>
             <a:fld id="{5BCAD085-E8A6-8845-BD4E-CB4CCA059FC4}" type="datetimeFigureOut">
               <a:rPr lang="en-US" smtClean="0"/>
-              <a:t>1/27/13</a:t>
+              <a:t>7/9/2026</a:t>
             </a:fld>
             <a:endParaRPr lang="en-US"/>
           </a:p>
@@ -2366,10 +2364,9 @@
           </a:lstStyle>
           <a:p>
             <a:r>
-              <a:rPr lang="en-US" smtClean="0"/>
+              <a:rPr lang="en-US"/>
               <a:t>Click to edit Master title style</a:t>
             </a:r>
-            <a:endParaRPr lang="en-US"/>
           </a:p>
         </p:txBody>
       </p:sp>
@@ -2493,7 +2490,7 @@
           <a:p>
             <a:pPr lvl="0"/>
             <a:r>
-              <a:rPr lang="en-US" smtClean="0"/>
+              <a:rPr lang="en-US"/>
               <a:t>Click to edit Master text styles</a:t>
             </a:r>
           </a:p>
@@ -2516,7 +2513,7 @@
           <a:p>
             <a:fld id="{5BCAD085-E8A6-8845-BD4E-CB4CCA059FC4}" type="datetimeFigureOut">
               <a:rPr lang="en-US" smtClean="0"/>
-              <a:t>1/27/13</a:t>
+              <a:t>7/9/2026</a:t>
             </a:fld>
             <a:endParaRPr lang="en-US"/>
           </a:p>
@@ -2625,10 +2622,9 @@
           <a:lstStyle/>
           <a:p>
             <a:r>
-              <a:rPr lang="en-US" smtClean="0"/>
+              <a:rPr lang="en-US"/>
               <a:t>Click to edit Master title style</a:t>
             </a:r>
-            <a:endParaRPr lang="en-US"/>
           </a:p>
         </p:txBody>
       </p:sp>
@@ -2659,38 +2655,37 @@
           <a:p>
             <a:pPr lvl="0"/>
             <a:r>
-              <a:rPr lang="en-US" smtClean="0"/>
+              <a:rPr lang="en-US"/>
               <a:t>Click to edit Master text styles</a:t>
             </a:r>
           </a:p>
           <a:p>
             <a:pPr lvl="1"/>
             <a:r>
-              <a:rPr lang="en-US" smtClean="0"/>
+              <a:rPr lang="en-US"/>
               <a:t>Second level</a:t>
             </a:r>
           </a:p>
           <a:p>
             <a:pPr lvl="2"/>
             <a:r>
-              <a:rPr lang="en-US" smtClean="0"/>
+              <a:rPr lang="en-US"/>
               <a:t>Third level</a:t>
             </a:r>
           </a:p>
           <a:p>
             <a:pPr lvl="3"/>
             <a:r>
-              <a:rPr lang="en-US" smtClean="0"/>
+              <a:rPr lang="en-US"/>
               <a:t>Fourth level</a:t>
             </a:r>
           </a:p>
           <a:p>
             <a:pPr lvl="4"/>
             <a:r>
-              <a:rPr lang="en-US" smtClean="0"/>
+              <a:rPr lang="en-US"/>
               <a:t>Fifth level</a:t>
             </a:r>
-            <a:endParaRPr lang="en-US"/>
           </a:p>
         </p:txBody>
       </p:sp>
@@ -2729,7 +2724,7 @@
           <a:p>
             <a:fld id="{5BCAD085-E8A6-8845-BD4E-CB4CCA059FC4}" type="datetimeFigureOut">
               <a:rPr lang="en-US" smtClean="0"/>
-              <a:t>1/27/13</a:t>
+              <a:t>7/9/2026</a:t>
             </a:fld>
             <a:endParaRPr lang="en-US"/>
           </a:p>
@@ -3088,7 +3083,7 @@
 </file>
 
 <file path=ppt/slides/slide1.xml><?xml version="1.0" encoding="utf-8"?>
-<p:sld xmlns:a="http://schemas.openxmlformats.org/drawingml/2006/main" xmlns:p="http://schemas.openxmlformats.org/presentationml/2006/main" xmlns:r="http://schemas.openxmlformats.org/officeDocument/2006/relationships">
+<p:sld xmlns:a="http://schemas.openxmlformats.org/drawingml/2006/main" xmlns:r="http://schemas.openxmlformats.org/officeDocument/2006/relationships" xmlns:p="http://schemas.openxmlformats.org/presentationml/2006/main">
   <p:cSld>
     <p:spTree>
       <p:nvGrpSpPr>
@@ -3096,7 +3091,14 @@
         <p:cNvGrpSpPr/>
         <p:nvPr/>
       </p:nvGrpSpPr>
-      <p:grpSpPr/>
+      <p:grpSpPr>
+        <a:xfrm>
+          <a:off x="0" y="0"/>
+          <a:ext cx="0" cy="0"/>
+          <a:chOff x="0" y="0"/>
+          <a:chExt cx="0" cy="0"/>
+        </a:xfrm>
+      </p:grpSpPr>
       <p:sp>
         <p:nvSpPr>
           <p:cNvPr id="2" name="Rectangle 1"/>
@@ -3105,7 +3107,7 @@
         </p:nvSpPr>
         <p:spPr>
           <a:xfrm>
-            <a:off x="0" y="0"/>
+            <a:off x="-2844472" y="274074"/>
             <a:ext cx="12188952" cy="6858000"/>
           </a:xfrm>
           <a:prstGeom prst="rect">
@@ -3139,6 +3141,7 @@
           <a:lstStyle/>
           <a:p>
             <a:pPr algn="ctr"/>
+            <a:endParaRPr/>
           </a:p>
         </p:txBody>
       </p:sp>
@@ -3184,6 +3187,7 @@
           <a:lstStyle/>
           <a:p>
             <a:pPr algn="ctr"/>
+            <a:endParaRPr/>
           </a:p>
         </p:txBody>
       </p:sp>
@@ -3229,6 +3233,7 @@
           <a:lstStyle/>
           <a:p>
             <a:pPr algn="ctr"/>
+            <a:endParaRPr/>
           </a:p>
         </p:txBody>
       </p:sp>
@@ -3433,7 +3438,7 @@
 </file>
 
 <file path=ppt/slides/slide10.xml><?xml version="1.0" encoding="utf-8"?>
-<p:sld xmlns:a="http://schemas.openxmlformats.org/drawingml/2006/main" xmlns:p="http://schemas.openxmlformats.org/presentationml/2006/main" xmlns:r="http://schemas.openxmlformats.org/officeDocument/2006/relationships">
+<p:sld xmlns:a="http://schemas.openxmlformats.org/drawingml/2006/main" xmlns:r="http://schemas.openxmlformats.org/officeDocument/2006/relationships" xmlns:p="http://schemas.openxmlformats.org/presentationml/2006/main">
   <p:cSld>
     <p:spTree>
       <p:nvGrpSpPr>
@@ -3441,7 +3446,14 @@
         <p:cNvGrpSpPr/>
         <p:nvPr/>
       </p:nvGrpSpPr>
-      <p:grpSpPr/>
+      <p:grpSpPr>
+        <a:xfrm>
+          <a:off x="0" y="0"/>
+          <a:ext cx="0" cy="0"/>
+          <a:chOff x="0" y="0"/>
+          <a:chExt cx="0" cy="0"/>
+        </a:xfrm>
+      </p:grpSpPr>
       <p:sp>
         <p:nvSpPr>
           <p:cNvPr id="2" name="Rectangle 1"/>
@@ -3484,6 +3496,7 @@
           <a:lstStyle/>
           <a:p>
             <a:pPr algn="ctr"/>
+            <a:endParaRPr/>
           </a:p>
         </p:txBody>
       </p:sp>
@@ -3529,6 +3542,7 @@
           <a:lstStyle/>
           <a:p>
             <a:pPr algn="ctr"/>
+            <a:endParaRPr/>
           </a:p>
         </p:txBody>
       </p:sp>
@@ -3608,6 +3622,7 @@
           <a:lstStyle/>
           <a:p>
             <a:pPr algn="ctr"/>
+            <a:endParaRPr/>
           </a:p>
         </p:txBody>
       </p:sp>
@@ -3755,6 +3770,7 @@
           <a:lstStyle/>
           <a:p>
             <a:pPr algn="ctr"/>
+            <a:endParaRPr/>
           </a:p>
         </p:txBody>
       </p:sp>
@@ -3800,6 +3816,7 @@
           <a:lstStyle/>
           <a:p>
             <a:pPr algn="ctr"/>
+            <a:endParaRPr/>
           </a:p>
         </p:txBody>
       </p:sp>
@@ -3947,6 +3964,7 @@
           <a:lstStyle/>
           <a:p>
             <a:pPr algn="ctr"/>
+            <a:endParaRPr/>
           </a:p>
         </p:txBody>
       </p:sp>
@@ -3992,6 +4010,7 @@
           <a:lstStyle/>
           <a:p>
             <a:pPr algn="ctr"/>
+            <a:endParaRPr/>
           </a:p>
         </p:txBody>
       </p:sp>
@@ -4139,6 +4158,7 @@
           <a:lstStyle/>
           <a:p>
             <a:pPr algn="ctr"/>
+            <a:endParaRPr/>
           </a:p>
         </p:txBody>
       </p:sp>
@@ -4184,6 +4204,7 @@
           <a:lstStyle/>
           <a:p>
             <a:pPr algn="ctr"/>
+            <a:endParaRPr/>
           </a:p>
         </p:txBody>
       </p:sp>
@@ -4331,6 +4352,7 @@
           <a:lstStyle/>
           <a:p>
             <a:pPr algn="ctr"/>
+            <a:endParaRPr/>
           </a:p>
         </p:txBody>
       </p:sp>
@@ -4376,6 +4398,7 @@
           <a:lstStyle/>
           <a:p>
             <a:pPr algn="ctr"/>
+            <a:endParaRPr/>
           </a:p>
         </p:txBody>
       </p:sp>
@@ -4523,6 +4546,7 @@
           <a:lstStyle/>
           <a:p>
             <a:pPr algn="ctr"/>
+            <a:endParaRPr/>
           </a:p>
         </p:txBody>
       </p:sp>
@@ -4569,7 +4593,7 @@
 </file>
 
 <file path=ppt/slides/slide2.xml><?xml version="1.0" encoding="utf-8"?>
-<p:sld xmlns:a="http://schemas.openxmlformats.org/drawingml/2006/main" xmlns:p="http://schemas.openxmlformats.org/presentationml/2006/main" xmlns:r="http://schemas.openxmlformats.org/officeDocument/2006/relationships">
+<p:sld xmlns:a="http://schemas.openxmlformats.org/drawingml/2006/main" xmlns:r="http://schemas.openxmlformats.org/officeDocument/2006/relationships" xmlns:p="http://schemas.openxmlformats.org/presentationml/2006/main">
   <p:cSld>
     <p:spTree>
       <p:nvGrpSpPr>
@@ -4577,7 +4601,14 @@
         <p:cNvGrpSpPr/>
         <p:nvPr/>
       </p:nvGrpSpPr>
-      <p:grpSpPr/>
+      <p:grpSpPr>
+        <a:xfrm>
+          <a:off x="0" y="0"/>
+          <a:ext cx="0" cy="0"/>
+          <a:chOff x="0" y="0"/>
+          <a:chExt cx="0" cy="0"/>
+        </a:xfrm>
+      </p:grpSpPr>
       <p:sp>
         <p:nvSpPr>
           <p:cNvPr id="2" name="Rectangle 1"/>
@@ -4620,6 +4651,7 @@
           <a:lstStyle/>
           <a:p>
             <a:pPr algn="ctr"/>
+            <a:endParaRPr/>
           </a:p>
         </p:txBody>
       </p:sp>
@@ -4665,6 +4697,7 @@
           <a:lstStyle/>
           <a:p>
             <a:pPr algn="ctr"/>
+            <a:endParaRPr/>
           </a:p>
         </p:txBody>
       </p:sp>
@@ -4759,14 +4792,11 @@
                 <a:spcPts val="500"/>
               </a:spcBef>
             </a:pPr>
-            <a:r>
-              <a:rPr sz="1500">
-                <a:solidFill>
-                  <a:srgbClr val="1C1C2E"/>
-                </a:solidFill>
-              </a:rPr>
-              <a:t/>
-            </a:r>
+            <a:endParaRPr sz="1500">
+              <a:solidFill>
+                <a:srgbClr val="1C1C2E"/>
+              </a:solidFill>
+            </a:endParaRPr>
           </a:p>
           <a:p>
             <a:pPr>
@@ -4849,14 +4879,11 @@
                 <a:spcPts val="500"/>
               </a:spcBef>
             </a:pPr>
-            <a:r>
-              <a:rPr sz="1500">
-                <a:solidFill>
-                  <a:srgbClr val="1C1C2E"/>
-                </a:solidFill>
-              </a:rPr>
-              <a:t/>
-            </a:r>
+            <a:endParaRPr sz="1500">
+              <a:solidFill>
+                <a:srgbClr val="1C1C2E"/>
+              </a:solidFill>
+            </a:endParaRPr>
           </a:p>
           <a:p>
             <a:pPr>
@@ -4909,14 +4936,11 @@
                 <a:spcPts val="500"/>
               </a:spcBef>
             </a:pPr>
-            <a:r>
-              <a:rPr sz="1500">
-                <a:solidFill>
-                  <a:srgbClr val="1C1C2E"/>
-                </a:solidFill>
-              </a:rPr>
-              <a:t/>
-            </a:r>
+            <a:endParaRPr sz="1500">
+              <a:solidFill>
+                <a:srgbClr val="1C1C2E"/>
+              </a:solidFill>
+            </a:endParaRPr>
           </a:p>
           <a:p>
             <a:pPr>
@@ -4983,7 +5007,7 @@
 </file>
 
 <file path=ppt/slides/slide3.xml><?xml version="1.0" encoding="utf-8"?>
-<p:sld xmlns:a="http://schemas.openxmlformats.org/drawingml/2006/main" xmlns:p="http://schemas.openxmlformats.org/presentationml/2006/main" xmlns:r="http://schemas.openxmlformats.org/officeDocument/2006/relationships">
+<p:sld xmlns:a="http://schemas.openxmlformats.org/drawingml/2006/main" xmlns:r="http://schemas.openxmlformats.org/officeDocument/2006/relationships" xmlns:p="http://schemas.openxmlformats.org/presentationml/2006/main">
   <p:cSld>
     <p:spTree>
       <p:nvGrpSpPr>
@@ -4991,7 +5015,14 @@
         <p:cNvGrpSpPr/>
         <p:nvPr/>
       </p:nvGrpSpPr>
-      <p:grpSpPr/>
+      <p:grpSpPr>
+        <a:xfrm>
+          <a:off x="0" y="0"/>
+          <a:ext cx="0" cy="0"/>
+          <a:chOff x="0" y="0"/>
+          <a:chExt cx="0" cy="0"/>
+        </a:xfrm>
+      </p:grpSpPr>
       <p:sp>
         <p:nvSpPr>
           <p:cNvPr id="2" name="Rectangle 1"/>
@@ -5034,6 +5065,7 @@
           <a:lstStyle/>
           <a:p>
             <a:pPr algn="ctr"/>
+            <a:endParaRPr/>
           </a:p>
         </p:txBody>
       </p:sp>
@@ -5079,6 +5111,7 @@
           <a:lstStyle/>
           <a:p>
             <a:pPr algn="ctr"/>
+            <a:endParaRPr/>
           </a:p>
         </p:txBody>
       </p:sp>
@@ -5158,6 +5191,7 @@
           <a:lstStyle/>
           <a:p>
             <a:pPr algn="ctr"/>
+            <a:endParaRPr/>
           </a:p>
         </p:txBody>
       </p:sp>
@@ -5248,6 +5282,7 @@
           <a:lstStyle/>
           <a:p>
             <a:pPr algn="ctr"/>
+            <a:endParaRPr/>
           </a:p>
         </p:txBody>
       </p:sp>
@@ -5444,6 +5479,7 @@
           <a:lstStyle/>
           <a:p>
             <a:pPr algn="ctr"/>
+            <a:endParaRPr/>
           </a:p>
         </p:txBody>
       </p:sp>
@@ -5640,6 +5676,7 @@
           <a:lstStyle/>
           <a:p>
             <a:pPr algn="ctr"/>
+            <a:endParaRPr/>
           </a:p>
         </p:txBody>
       </p:sp>
@@ -5837,7 +5874,7 @@
 </file>
 
 <file path=ppt/slides/slide4.xml><?xml version="1.0" encoding="utf-8"?>
-<p:sld xmlns:a="http://schemas.openxmlformats.org/drawingml/2006/main" xmlns:p="http://schemas.openxmlformats.org/presentationml/2006/main" xmlns:r="http://schemas.openxmlformats.org/officeDocument/2006/relationships">
+<p:sld xmlns:a="http://schemas.openxmlformats.org/drawingml/2006/main" xmlns:r="http://schemas.openxmlformats.org/officeDocument/2006/relationships" xmlns:p="http://schemas.openxmlformats.org/presentationml/2006/main">
   <p:cSld>
     <p:spTree>
       <p:nvGrpSpPr>
@@ -5845,7 +5882,14 @@
         <p:cNvGrpSpPr/>
         <p:nvPr/>
       </p:nvGrpSpPr>
-      <p:grpSpPr/>
+      <p:grpSpPr>
+        <a:xfrm>
+          <a:off x="0" y="0"/>
+          <a:ext cx="0" cy="0"/>
+          <a:chOff x="0" y="0"/>
+          <a:chExt cx="0" cy="0"/>
+        </a:xfrm>
+      </p:grpSpPr>
       <p:sp>
         <p:nvSpPr>
           <p:cNvPr id="2" name="Rectangle 1"/>
@@ -5888,6 +5932,7 @@
           <a:lstStyle/>
           <a:p>
             <a:pPr algn="ctr"/>
+            <a:endParaRPr/>
           </a:p>
         </p:txBody>
       </p:sp>
@@ -5933,6 +5978,7 @@
           <a:lstStyle/>
           <a:p>
             <a:pPr algn="ctr"/>
+            <a:endParaRPr/>
           </a:p>
         </p:txBody>
       </p:sp>
@@ -6012,6 +6058,7 @@
           <a:lstStyle/>
           <a:p>
             <a:pPr algn="ctr"/>
+            <a:endParaRPr/>
           </a:p>
         </p:txBody>
       </p:sp>
@@ -6215,6 +6262,7 @@
           <a:lstStyle/>
           <a:p>
             <a:pPr algn="ctr"/>
+            <a:endParaRPr/>
           </a:p>
         </p:txBody>
       </p:sp>
@@ -6418,6 +6466,7 @@
           <a:lstStyle/>
           <a:p>
             <a:pPr algn="ctr"/>
+            <a:endParaRPr/>
           </a:p>
         </p:txBody>
       </p:sp>
@@ -6587,6 +6636,7 @@
           <a:lstStyle/>
           <a:p>
             <a:pPr algn="ctr"/>
+            <a:endParaRPr/>
           </a:p>
         </p:txBody>
       </p:sp>
@@ -6720,7 +6770,7 @@
 </file>
 
 <file path=ppt/slides/slide5.xml><?xml version="1.0" encoding="utf-8"?>
-<p:sld xmlns:a="http://schemas.openxmlformats.org/drawingml/2006/main" xmlns:p="http://schemas.openxmlformats.org/presentationml/2006/main" xmlns:r="http://schemas.openxmlformats.org/officeDocument/2006/relationships">
+<p:sld xmlns:a="http://schemas.openxmlformats.org/drawingml/2006/main" xmlns:r="http://schemas.openxmlformats.org/officeDocument/2006/relationships" xmlns:p="http://schemas.openxmlformats.org/presentationml/2006/main">
   <p:cSld>
     <p:spTree>
       <p:nvGrpSpPr>
@@ -6728,7 +6778,14 @@
         <p:cNvGrpSpPr/>
         <p:nvPr/>
       </p:nvGrpSpPr>
-      <p:grpSpPr/>
+      <p:grpSpPr>
+        <a:xfrm>
+          <a:off x="0" y="0"/>
+          <a:ext cx="0" cy="0"/>
+          <a:chOff x="0" y="0"/>
+          <a:chExt cx="0" cy="0"/>
+        </a:xfrm>
+      </p:grpSpPr>
       <p:sp>
         <p:nvSpPr>
           <p:cNvPr id="2" name="Rectangle 1"/>
@@ -6771,6 +6828,7 @@
           <a:lstStyle/>
           <a:p>
             <a:pPr algn="ctr"/>
+            <a:endParaRPr/>
           </a:p>
         </p:txBody>
       </p:sp>
@@ -6816,6 +6874,7 @@
           <a:lstStyle/>
           <a:p>
             <a:pPr algn="ctr"/>
+            <a:endParaRPr/>
           </a:p>
         </p:txBody>
       </p:sp>
@@ -6895,6 +6954,7 @@
           <a:lstStyle/>
           <a:p>
             <a:pPr algn="ctr"/>
+            <a:endParaRPr/>
           </a:p>
         </p:txBody>
       </p:sp>
@@ -7620,6 +7680,7 @@
           <a:lstStyle/>
           <a:p>
             <a:pPr algn="ctr"/>
+            <a:endParaRPr/>
           </a:p>
         </p:txBody>
       </p:sp>
@@ -7767,6 +7828,7 @@
           <a:lstStyle/>
           <a:p>
             <a:pPr algn="ctr"/>
+            <a:endParaRPr/>
           </a:p>
         </p:txBody>
       </p:sp>
@@ -7948,6 +8010,7 @@
           <a:lstStyle/>
           <a:p>
             <a:pPr algn="ctr"/>
+            <a:endParaRPr/>
           </a:p>
         </p:txBody>
       </p:sp>
@@ -8062,7 +8125,7 @@
 </file>
 
 <file path=ppt/slides/slide6.xml><?xml version="1.0" encoding="utf-8"?>
-<p:sld xmlns:a="http://schemas.openxmlformats.org/drawingml/2006/main" xmlns:p="http://schemas.openxmlformats.org/presentationml/2006/main" xmlns:r="http://schemas.openxmlformats.org/officeDocument/2006/relationships">
+<p:sld xmlns:a="http://schemas.openxmlformats.org/drawingml/2006/main" xmlns:r="http://schemas.openxmlformats.org/officeDocument/2006/relationships" xmlns:p="http://schemas.openxmlformats.org/presentationml/2006/main">
   <p:cSld>
     <p:spTree>
       <p:nvGrpSpPr>
@@ -8070,7 +8133,14 @@
         <p:cNvGrpSpPr/>
         <p:nvPr/>
       </p:nvGrpSpPr>
-      <p:grpSpPr/>
+      <p:grpSpPr>
+        <a:xfrm>
+          <a:off x="0" y="0"/>
+          <a:ext cx="0" cy="0"/>
+          <a:chOff x="0" y="0"/>
+          <a:chExt cx="0" cy="0"/>
+        </a:xfrm>
+      </p:grpSpPr>
       <p:sp>
         <p:nvSpPr>
           <p:cNvPr id="2" name="Rectangle 1"/>
@@ -8113,6 +8183,7 @@
           <a:lstStyle/>
           <a:p>
             <a:pPr algn="ctr"/>
+            <a:endParaRPr/>
           </a:p>
         </p:txBody>
       </p:sp>
@@ -8158,6 +8229,7 @@
           <a:lstStyle/>
           <a:p>
             <a:pPr algn="ctr"/>
+            <a:endParaRPr/>
           </a:p>
         </p:txBody>
       </p:sp>
@@ -8285,6 +8357,7 @@
           <a:lstStyle/>
           <a:p>
             <a:pPr algn="ctr"/>
+            <a:endParaRPr/>
           </a:p>
         </p:txBody>
       </p:sp>
@@ -8670,6 +8743,7 @@
           <a:lstStyle/>
           <a:p>
             <a:pPr algn="ctr"/>
+            <a:endParaRPr/>
           </a:p>
         </p:txBody>
       </p:sp>
@@ -8716,7 +8790,7 @@
 </file>
 
 <file path=ppt/slides/slide7.xml><?xml version="1.0" encoding="utf-8"?>
-<p:sld xmlns:a="http://schemas.openxmlformats.org/drawingml/2006/main" xmlns:p="http://schemas.openxmlformats.org/presentationml/2006/main" xmlns:r="http://schemas.openxmlformats.org/officeDocument/2006/relationships">
+<p:sld xmlns:a="http://schemas.openxmlformats.org/drawingml/2006/main" xmlns:r="http://schemas.openxmlformats.org/officeDocument/2006/relationships" xmlns:p="http://schemas.openxmlformats.org/presentationml/2006/main">
   <p:cSld>
     <p:spTree>
       <p:nvGrpSpPr>
@@ -8724,7 +8798,14 @@
         <p:cNvGrpSpPr/>
         <p:nvPr/>
       </p:nvGrpSpPr>
-      <p:grpSpPr/>
+      <p:grpSpPr>
+        <a:xfrm>
+          <a:off x="0" y="0"/>
+          <a:ext cx="0" cy="0"/>
+          <a:chOff x="0" y="0"/>
+          <a:chExt cx="0" cy="0"/>
+        </a:xfrm>
+      </p:grpSpPr>
       <p:sp>
         <p:nvSpPr>
           <p:cNvPr id="2" name="Rectangle 1"/>
@@ -8767,6 +8848,7 @@
           <a:lstStyle/>
           <a:p>
             <a:pPr algn="ctr"/>
+            <a:endParaRPr/>
           </a:p>
         </p:txBody>
       </p:sp>
@@ -8812,6 +8894,7 @@
           <a:lstStyle/>
           <a:p>
             <a:pPr algn="ctr"/>
+            <a:endParaRPr/>
           </a:p>
         </p:txBody>
       </p:sp>
@@ -8882,7 +8965,7 @@
 </file>
 
 <file path=ppt/slides/slide8.xml><?xml version="1.0" encoding="utf-8"?>
-<p:sld xmlns:a="http://schemas.openxmlformats.org/drawingml/2006/main" xmlns:p="http://schemas.openxmlformats.org/presentationml/2006/main" xmlns:r="http://schemas.openxmlformats.org/officeDocument/2006/relationships">
+<p:sld xmlns:a="http://schemas.openxmlformats.org/drawingml/2006/main" xmlns:r="http://schemas.openxmlformats.org/officeDocument/2006/relationships" xmlns:p="http://schemas.openxmlformats.org/presentationml/2006/main">
   <p:cSld>
     <p:spTree>
       <p:nvGrpSpPr>
@@ -8890,7 +8973,14 @@
         <p:cNvGrpSpPr/>
         <p:nvPr/>
       </p:nvGrpSpPr>
-      <p:grpSpPr/>
+      <p:grpSpPr>
+        <a:xfrm>
+          <a:off x="0" y="0"/>
+          <a:ext cx="0" cy="0"/>
+          <a:chOff x="0" y="0"/>
+          <a:chExt cx="0" cy="0"/>
+        </a:xfrm>
+      </p:grpSpPr>
       <p:sp>
         <p:nvSpPr>
           <p:cNvPr id="2" name="Rectangle 1"/>
@@ -8933,6 +9023,7 @@
           <a:lstStyle/>
           <a:p>
             <a:pPr algn="ctr"/>
+            <a:endParaRPr/>
           </a:p>
         </p:txBody>
       </p:sp>
@@ -8978,6 +9069,7 @@
           <a:lstStyle/>
           <a:p>
             <a:pPr algn="ctr"/>
+            <a:endParaRPr/>
           </a:p>
         </p:txBody>
       </p:sp>
@@ -9057,6 +9149,7 @@
           <a:lstStyle/>
           <a:p>
             <a:pPr algn="ctr"/>
+            <a:endParaRPr/>
           </a:p>
         </p:txBody>
       </p:sp>
@@ -9136,6 +9229,7 @@
           <a:lstStyle/>
           <a:p>
             <a:pPr algn="ctr"/>
+            <a:endParaRPr/>
           </a:p>
         </p:txBody>
       </p:sp>
@@ -9283,6 +9377,7 @@
           <a:lstStyle/>
           <a:p>
             <a:pPr algn="ctr"/>
+            <a:endParaRPr/>
           </a:p>
         </p:txBody>
       </p:sp>
@@ -9430,6 +9525,7 @@
           <a:lstStyle/>
           <a:p>
             <a:pPr algn="ctr"/>
+            <a:endParaRPr/>
           </a:p>
         </p:txBody>
       </p:sp>
@@ -9577,6 +9673,7 @@
           <a:lstStyle/>
           <a:p>
             <a:pPr algn="ctr"/>
+            <a:endParaRPr/>
           </a:p>
         </p:txBody>
       </p:sp>
@@ -9724,6 +9821,7 @@
           <a:lstStyle/>
           <a:p>
             <a:pPr algn="ctr"/>
+            <a:endParaRPr/>
           </a:p>
         </p:txBody>
       </p:sp>
@@ -9871,6 +9969,7 @@
           <a:lstStyle/>
           <a:p>
             <a:pPr algn="ctr"/>
+            <a:endParaRPr/>
           </a:p>
         </p:txBody>
       </p:sp>
@@ -10018,6 +10117,7 @@
           <a:lstStyle/>
           <a:p>
             <a:pPr algn="ctr"/>
+            <a:endParaRPr/>
           </a:p>
         </p:txBody>
       </p:sp>
@@ -10399,6 +10499,7 @@
           <a:lstStyle/>
           <a:p>
             <a:pPr algn="ctr"/>
+            <a:endParaRPr/>
           </a:p>
         </p:txBody>
       </p:sp>
@@ -10445,7 +10546,7 @@
 </file>
 
 <file path=ppt/slides/slide9.xml><?xml version="1.0" encoding="utf-8"?>
-<p:sld xmlns:a="http://schemas.openxmlformats.org/drawingml/2006/main" xmlns:p="http://schemas.openxmlformats.org/presentationml/2006/main" xmlns:r="http://schemas.openxmlformats.org/officeDocument/2006/relationships">
+<p:sld xmlns:a="http://schemas.openxmlformats.org/drawingml/2006/main" xmlns:r="http://schemas.openxmlformats.org/officeDocument/2006/relationships" xmlns:p="http://schemas.openxmlformats.org/presentationml/2006/main">
   <p:cSld>
     <p:spTree>
       <p:nvGrpSpPr>
@@ -10453,7 +10554,14 @@
         <p:cNvGrpSpPr/>
         <p:nvPr/>
       </p:nvGrpSpPr>
-      <p:grpSpPr/>
+      <p:grpSpPr>
+        <a:xfrm>
+          <a:off x="0" y="0"/>
+          <a:ext cx="0" cy="0"/>
+          <a:chOff x="0" y="0"/>
+          <a:chExt cx="0" cy="0"/>
+        </a:xfrm>
+      </p:grpSpPr>
       <p:sp>
         <p:nvSpPr>
           <p:cNvPr id="2" name="Rectangle 1"/>
@@ -10496,6 +10604,7 @@
           <a:lstStyle/>
           <a:p>
             <a:pPr algn="ctr"/>
+            <a:endParaRPr/>
           </a:p>
         </p:txBody>
       </p:sp>
@@ -10541,6 +10650,7 @@
           <a:lstStyle/>
           <a:p>
             <a:pPr algn="ctr"/>
+            <a:endParaRPr/>
           </a:p>
         </p:txBody>
       </p:sp>
@@ -10678,6 +10788,7 @@
           <a:lstStyle/>
           <a:p>
             <a:pPr algn="ctr"/>
+            <a:endParaRPr/>
           </a:p>
         </p:txBody>
       </p:sp>
@@ -10791,6 +10902,7 @@
           <a:lstStyle/>
           <a:p>
             <a:pPr algn="ctr"/>
+            <a:endParaRPr/>
           </a:p>
         </p:txBody>
       </p:sp>
@@ -10904,6 +11016,7 @@
           <a:lstStyle/>
           <a:p>
             <a:pPr algn="ctr"/>
+            <a:endParaRPr/>
           </a:p>
         </p:txBody>
       </p:sp>
@@ -11017,6 +11130,7 @@
           <a:lstStyle/>
           <a:p>
             <a:pPr algn="ctr"/>
+            <a:endParaRPr/>
           </a:p>
         </p:txBody>
       </p:sp>
@@ -11130,6 +11244,7 @@
           <a:lstStyle/>
           <a:p>
             <a:pPr algn="ctr"/>
+            <a:endParaRPr/>
           </a:p>
         </p:txBody>
       </p:sp>
@@ -11243,6 +11358,7 @@
           <a:lstStyle/>
           <a:p>
             <a:pPr algn="ctr"/>
+            <a:endParaRPr/>
           </a:p>
         </p:txBody>
       </p:sp>
@@ -11356,6 +11472,7 @@
           <a:lstStyle/>
           <a:p>
             <a:pPr algn="ctr"/>
+            <a:endParaRPr/>
           </a:p>
         </p:txBody>
       </p:sp>

</xml_diff>